<commit_message>
fix: the numeral box is one numeral line (Q-48, audit 05)
figure() no longer rounds the numeral's box up to whole grid rows: it is
exactly one numeral line (size x 1.2 + 0.01 mm, B-21), and the label's
box starts directly below. A presented statement or close (23 rows,
163.0 pt) now holds a figure: 144.03 + 16.83 = 160.86 pt. The pack does
not change; this supersedes Q-43's rounding. A region shorter than one
numeral line and one label line still raises DoesNotFit, now naming
both in points.

Tests: the numeral box is one line; presented statement and close hold
a figure; the refusal, on a region patched to 22 rows; the fit stress
refuses no component at its shortest in any mode or voice (it refused
the figure on those two layouts); the FX-21 sweep refuses nothing. The
specimens are rebuilt: only their figure slide changes.

Co-Authored-By: Claude Opus 5.5 (1M context) <noreply@anthropic.com>
</commit_message>
<xml_diff>
--- a/fixtures/packs/swiss-specimen-presented-neutral.pptx
+++ b/fixtures/packs/swiss-specimen-presented-neutral.pptx
@@ -3552,7 +3552,7 @@
         <p:spPr>
           <a:xfrm>
             <a:off x="540000" y="2349000"/>
-            <a:ext cx="7348000" cy="1890000"/>
+            <a:ext cx="7348000" cy="1829160"/>
           </a:xfrm>
           <a:prstGeom prst="rect">
             <a:avLst/>
@@ -3597,8 +3597,8 @@
         </p:nvSpPr>
         <p:spPr>
           <a:xfrm>
-            <a:off x="540000" y="4239000"/>
-            <a:ext cx="7348000" cy="1440000"/>
+            <a:off x="540000" y="4178160"/>
+            <a:ext cx="7348000" cy="1500840"/>
           </a:xfrm>
           <a:prstGeom prst="rect">
             <a:avLst/>

</xml_diff>